<commit_message>
feat(pitch): end the deck at Why Sehat wins
Co-Authored-By: Claude Opus 5.5 <noreply@anthropic.com>
</commit_message>
<xml_diff>
--- a/pitch/Sehat-GRAVITON-2026.pptx
+++ b/pitch/Sehat-GRAVITON-2026.pptx
@@ -16,7 +16,6 @@
     <p:sldId id="264" r:id="rId15"/>
     <p:sldId id="265" r:id="rId16"/>
     <p:sldId id="266" r:id="rId17"/>
-    <p:sldId id="267" r:id="rId18"/>
   </p:sldIdLst>
   <p:sldSz cx="12191695" cy="6858000" type="screen4x3"/>
   <p:notesSz cx="6858000" cy="9144000"/>
@@ -5078,474 +5077,6 @@
                 <a:latin typeface="Plus Jakarta Sans"/>
               </a:rPr>
               <a:t>Sehat Copilot was our earlier patient app; at GRAVITON we built the network around it</a:t>
-            </a:r>
-          </a:p>
-        </p:txBody>
-      </p:sp>
-    </p:spTree>
-  </p:cSld>
-  <p:clrMapOvr>
-    <a:masterClrMapping/>
-  </p:clrMapOvr>
-</p:sld>
-</file>
-
-<file path=ppt/slides/slide12.xml><?xml version="1.0" encoding="utf-8"?>
-<p:sld xmlns:a="http://schemas.openxmlformats.org/drawingml/2006/main" xmlns:p="http://schemas.openxmlformats.org/presentationml/2006/main" xmlns:r="http://schemas.openxmlformats.org/officeDocument/2006/relationships">
-  <p:cSld>
-    <p:spTree>
-      <p:nvGrpSpPr>
-        <p:cNvPr id="1" name=""/>
-        <p:cNvGrpSpPr/>
-        <p:nvPr/>
-      </p:nvGrpSpPr>
-      <p:grpSpPr/>
-      <p:sp>
-        <p:nvSpPr>
-          <p:cNvPr id="2" name="Rectangle 1"/>
-          <p:cNvSpPr/>
-          <p:nvPr/>
-        </p:nvSpPr>
-        <p:spPr>
-          <a:xfrm>
-            <a:off x="0" y="0"/>
-            <a:ext cx="12191695" cy="91440"/>
-          </a:xfrm>
-          <a:prstGeom prst="rect">
-            <a:avLst/>
-          </a:prstGeom>
-          <a:solidFill>
-            <a:srgbClr val="0774C4"/>
-          </a:solidFill>
-          <a:ln>
-            <a:noFill/>
-          </a:ln>
-          <a:effectLst/>
-        </p:spPr>
-        <p:style>
-          <a:lnRef idx="1">
-            <a:schemeClr val="accent1"/>
-          </a:lnRef>
-          <a:fillRef idx="3">
-            <a:schemeClr val="accent1"/>
-          </a:fillRef>
-          <a:effectRef idx="2">
-            <a:schemeClr val="accent1"/>
-          </a:effectRef>
-          <a:fontRef idx="minor">
-            <a:schemeClr val="lt1"/>
-          </a:fontRef>
-        </p:style>
-        <p:txBody>
-          <a:bodyPr rtlCol="0" anchor="ctr"/>
-          <a:lstStyle/>
-          <a:p>
-            <a:pPr algn="ctr"/>
-          </a:p>
-        </p:txBody>
-      </p:sp>
-      <p:sp>
-        <p:nvSpPr>
-          <p:cNvPr id="3" name="TextBox 2"/>
-          <p:cNvSpPr txBox="1"/>
-          <p:nvPr/>
-        </p:nvSpPr>
-        <p:spPr>
-          <a:xfrm>
-            <a:off x="640080" y="384048"/>
-            <a:ext cx="8229600" cy="365760"/>
-          </a:xfrm>
-          <a:prstGeom prst="rect">
-            <a:avLst/>
-          </a:prstGeom>
-          <a:noFill/>
-        </p:spPr>
-        <p:txBody>
-          <a:bodyPr wrap="square" anchor="t" lIns="45720" rIns="45720">
-            <a:spAutoFit/>
-          </a:bodyPr>
-          <a:lstStyle/>
-          <a:p>
-            <a:pPr algn="l">
-              <a:spcAft>
-                <a:spcPts val="800"/>
-              </a:spcAft>
-            </a:pPr>
-            <a:r>
-              <a:rPr sz="1300" b="1">
-                <a:solidFill>
-                  <a:srgbClr val="0774C4"/>
-                </a:solidFill>
-                <a:latin typeface="Plus Jakarta Sans"/>
-              </a:rPr>
-              <a:t>TEAM &amp; ASK</a:t>
-            </a:r>
-          </a:p>
-        </p:txBody>
-      </p:sp>
-      <p:sp>
-        <p:nvSpPr>
-          <p:cNvPr id="4" name="TextBox 3"/>
-          <p:cNvSpPr txBox="1"/>
-          <p:nvPr/>
-        </p:nvSpPr>
-        <p:spPr>
-          <a:xfrm>
-            <a:off x="640080" y="685800"/>
-            <a:ext cx="10972800" cy="822960"/>
-          </a:xfrm>
-          <a:prstGeom prst="rect">
-            <a:avLst/>
-          </a:prstGeom>
-          <a:noFill/>
-        </p:spPr>
-        <p:txBody>
-          <a:bodyPr wrap="square" anchor="t" lIns="45720" rIns="45720">
-            <a:spAutoFit/>
-          </a:bodyPr>
-          <a:lstStyle/>
-          <a:p>
-            <a:pPr algn="l">
-              <a:spcAft>
-                <a:spcPts val="800"/>
-              </a:spcAft>
-            </a:pPr>
-            <a:r>
-              <a:rPr sz="3600" b="1">
-                <a:solidFill>
-                  <a:srgbClr val="0F172A"/>
-                </a:solidFill>
-                <a:latin typeface="Manrope"/>
-              </a:rPr>
-              <a:t>Team ANTIJAREX</a:t>
-            </a:r>
-          </a:p>
-        </p:txBody>
-      </p:sp>
-      <p:sp>
-        <p:nvSpPr>
-          <p:cNvPr id="5" name="TextBox 4"/>
-          <p:cNvSpPr txBox="1"/>
-          <p:nvPr/>
-        </p:nvSpPr>
-        <p:spPr>
-          <a:xfrm>
-            <a:off x="640080" y="6355080"/>
-            <a:ext cx="8229600" cy="320040"/>
-          </a:xfrm>
-          <a:prstGeom prst="rect">
-            <a:avLst/>
-          </a:prstGeom>
-          <a:noFill/>
-        </p:spPr>
-        <p:txBody>
-          <a:bodyPr wrap="square" anchor="t" lIns="45720" rIns="45720">
-            <a:spAutoFit/>
-          </a:bodyPr>
-          <a:lstStyle/>
-          <a:p>
-            <a:pPr algn="l">
-              <a:spcAft>
-                <a:spcPts val="800"/>
-              </a:spcAft>
-            </a:pPr>
-            <a:r>
-              <a:rPr sz="1100" b="0">
-                <a:solidFill>
-                  <a:srgbClr val="5B6B80"/>
-                </a:solidFill>
-                <a:latin typeface="Plus Jakarta Sans"/>
-              </a:rPr>
-              <a:t>Sehat  ·  Team ANTIJAREX  ·  GRAVITON 2026</a:t>
-            </a:r>
-          </a:p>
-        </p:txBody>
-      </p:sp>
-      <p:sp>
-        <p:nvSpPr>
-          <p:cNvPr id="6" name="TextBox 5"/>
-          <p:cNvSpPr txBox="1"/>
-          <p:nvPr/>
-        </p:nvSpPr>
-        <p:spPr>
-          <a:xfrm>
-            <a:off x="10972800" y="6355080"/>
-            <a:ext cx="640080" cy="320040"/>
-          </a:xfrm>
-          <a:prstGeom prst="rect">
-            <a:avLst/>
-          </a:prstGeom>
-          <a:noFill/>
-        </p:spPr>
-        <p:txBody>
-          <a:bodyPr wrap="square" anchor="t" lIns="45720" rIns="45720">
-            <a:spAutoFit/>
-          </a:bodyPr>
-          <a:lstStyle/>
-          <a:p>
-            <a:pPr algn="r">
-              <a:spcAft>
-                <a:spcPts val="800"/>
-              </a:spcAft>
-            </a:pPr>
-            <a:r>
-              <a:rPr sz="1100" b="1">
-                <a:solidFill>
-                  <a:srgbClr val="5B6B80"/>
-                </a:solidFill>
-                <a:latin typeface="Plus Jakarta Sans"/>
-              </a:rPr>
-              <a:t>12</a:t>
-            </a:r>
-          </a:p>
-        </p:txBody>
-      </p:sp>
-      <p:sp>
-        <p:nvSpPr>
-          <p:cNvPr id="7" name="TextBox 6"/>
-          <p:cNvSpPr txBox="1"/>
-          <p:nvPr/>
-        </p:nvSpPr>
-        <p:spPr>
-          <a:xfrm>
-            <a:off x="640080" y="1737360"/>
-            <a:ext cx="5303520" cy="2377440"/>
-          </a:xfrm>
-          <a:prstGeom prst="rect">
-            <a:avLst/>
-          </a:prstGeom>
-          <a:noFill/>
-        </p:spPr>
-        <p:txBody>
-          <a:bodyPr wrap="square" anchor="t" lIns="45720" rIns="45720">
-            <a:spAutoFit/>
-          </a:bodyPr>
-          <a:lstStyle/>
-          <a:p>
-            <a:pPr algn="l">
-              <a:spcAft>
-                <a:spcPts val="600"/>
-              </a:spcAft>
-            </a:pPr>
-            <a:r>
-              <a:rPr sz="2000" b="0">
-                <a:solidFill>
-                  <a:srgbClr val="0F172A"/>
-                </a:solidFill>
-                <a:latin typeface="Plus Jakarta Sans"/>
-              </a:rPr>
-              <a:t>Team members: (add names and roles)</a:t>
-            </a:r>
-          </a:p>
-          <a:p>
-            <a:pPr algn="l">
-              <a:spcAft>
-                <a:spcPts val="600"/>
-              </a:spcAft>
-            </a:pPr>
-            <a:r>
-              <a:rPr sz="2000" b="0">
-                <a:solidFill>
-                  <a:srgbClr val="0F172A"/>
-                </a:solidFill>
-                <a:latin typeface="Plus Jakarta Sans"/>
-              </a:rPr>
-              <a:t/>
-            </a:r>
-          </a:p>
-          <a:p>
-            <a:pPr algn="l">
-              <a:spcAft>
-                <a:spcPts val="600"/>
-              </a:spcAft>
-            </a:pPr>
-            <a:r>
-              <a:rPr sz="2000" b="0">
-                <a:solidFill>
-                  <a:srgbClr val="0F172A"/>
-                </a:solidFill>
-                <a:latin typeface="Plus Jakarta Sans"/>
-              </a:rPr>
-              <a:t>CGC University · GRAVITON 2026 (24 h, open innovation)</a:t>
-            </a:r>
-          </a:p>
-        </p:txBody>
-      </p:sp>
-      <p:sp>
-        <p:nvSpPr>
-          <p:cNvPr id="8" name="Rounded Rectangle 7"/>
-          <p:cNvSpPr/>
-          <p:nvPr/>
-        </p:nvSpPr>
-        <p:spPr>
-          <a:xfrm>
-            <a:off x="6309360" y="1737360"/>
-            <a:ext cx="5257800" cy="2743200"/>
-          </a:xfrm>
-          <a:prstGeom prst="roundRect">
-            <a:avLst>
-              <a:gd name="adj" fmla="val 8000"/>
-            </a:avLst>
-          </a:prstGeom>
-          <a:solidFill>
-            <a:srgbClr val="EAF3FE"/>
-          </a:solidFill>
-          <a:ln>
-            <a:noFill/>
-          </a:ln>
-          <a:effectLst/>
-        </p:spPr>
-        <p:style>
-          <a:lnRef idx="1">
-            <a:schemeClr val="accent1"/>
-          </a:lnRef>
-          <a:fillRef idx="3">
-            <a:schemeClr val="accent1"/>
-          </a:fillRef>
-          <a:effectRef idx="2">
-            <a:schemeClr val="accent1"/>
-          </a:effectRef>
-          <a:fontRef idx="minor">
-            <a:schemeClr val="lt1"/>
-          </a:fontRef>
-        </p:style>
-        <p:txBody>
-          <a:bodyPr rtlCol="0" anchor="ctr"/>
-          <a:lstStyle/>
-          <a:p>
-            <a:pPr algn="ctr"/>
-          </a:p>
-        </p:txBody>
-      </p:sp>
-      <p:sp>
-        <p:nvSpPr>
-          <p:cNvPr id="9" name="TextBox 8"/>
-          <p:cNvSpPr txBox="1"/>
-          <p:nvPr/>
-        </p:nvSpPr>
-        <p:spPr>
-          <a:xfrm>
-            <a:off x="6583680" y="1920240"/>
-            <a:ext cx="4754880" cy="457200"/>
-          </a:xfrm>
-          <a:prstGeom prst="rect">
-            <a:avLst/>
-          </a:prstGeom>
-          <a:noFill/>
-        </p:spPr>
-        <p:txBody>
-          <a:bodyPr wrap="square" anchor="t" lIns="45720" rIns="45720">
-            <a:spAutoFit/>
-          </a:bodyPr>
-          <a:lstStyle/>
-          <a:p>
-            <a:pPr algn="l">
-              <a:spcAft>
-                <a:spcPts val="800"/>
-              </a:spcAft>
-            </a:pPr>
-            <a:r>
-              <a:rPr sz="2400" b="1">
-                <a:solidFill>
-                  <a:srgbClr val="0774C4"/>
-                </a:solidFill>
-                <a:latin typeface="Manrope"/>
-              </a:rPr>
-              <a:t>Our ask</a:t>
-            </a:r>
-          </a:p>
-        </p:txBody>
-      </p:sp>
-      <p:sp>
-        <p:nvSpPr>
-          <p:cNvPr id="10" name="TextBox 9"/>
-          <p:cNvSpPr txBox="1"/>
-          <p:nvPr/>
-        </p:nvSpPr>
-        <p:spPr>
-          <a:xfrm>
-            <a:off x="6583680" y="2514600"/>
-            <a:ext cx="4754880" cy="1828800"/>
-          </a:xfrm>
-          <a:prstGeom prst="rect">
-            <a:avLst/>
-          </a:prstGeom>
-          <a:noFill/>
-        </p:spPr>
-        <p:txBody>
-          <a:bodyPr wrap="square" anchor="t" lIns="45720" rIns="45720">
-            <a:spAutoFit/>
-          </a:bodyPr>
-          <a:lstStyle/>
-          <a:p>
-            <a:pPr algn="l">
-              <a:spcAft>
-                <a:spcPts val="800"/>
-              </a:spcAft>
-            </a:pPr>
-            <a:r>
-              <a:rPr sz="1700" b="0">
-                <a:solidFill>
-                  <a:srgbClr val="0F172A"/>
-                </a:solidFill>
-                <a:latin typeface="Plus Jakarta Sans"/>
-              </a:rPr>
-              <a:t>A 30-day pilot in Mohali: 1 hospital, 5 pharmacies, 1 distributor and their patients.</a:t>
-            </a:r>
-          </a:p>
-          <a:p>
-            <a:pPr algn="l">
-              <a:spcAft>
-                <a:spcPts val="800"/>
-              </a:spcAft>
-            </a:pPr>
-            <a:r>
-              <a:rPr sz="1700" b="0">
-                <a:solidFill>
-                  <a:srgbClr val="0F172A"/>
-                </a:solidFill>
-                <a:latin typeface="Plus Jakarta Sans"/>
-              </a:rPr>
-              <a:t>Mentorship on health-data compliance.</a:t>
-            </a:r>
-          </a:p>
-        </p:txBody>
-      </p:sp>
-      <p:sp>
-        <p:nvSpPr>
-          <p:cNvPr id="11" name="TextBox 10"/>
-          <p:cNvSpPr txBox="1"/>
-          <p:nvPr/>
-        </p:nvSpPr>
-        <p:spPr>
-          <a:xfrm>
-            <a:off x="640080" y="5029200"/>
-            <a:ext cx="10972800" cy="548640"/>
-          </a:xfrm>
-          <a:prstGeom prst="rect">
-            <a:avLst/>
-          </a:prstGeom>
-          <a:noFill/>
-        </p:spPr>
-        <p:txBody>
-          <a:bodyPr wrap="square" anchor="t" lIns="45720" rIns="45720">
-            <a:spAutoFit/>
-          </a:bodyPr>
-          <a:lstStyle/>
-          <a:p>
-            <a:pPr algn="l">
-              <a:spcAft>
-                <a:spcPts val="800"/>
-              </a:spcAft>
-            </a:pPr>
-            <a:r>
-              <a:rPr sz="3000" b="1">
-                <a:solidFill>
-                  <a:srgbClr val="0774C4"/>
-                </a:solidFill>
-                <a:latin typeface="Manrope"/>
-              </a:rPr>
-              <a:t>sehat-ashen.vercel.app</a:t>
             </a:r>
           </a:p>
         </p:txBody>

</xml_diff>

<commit_message>
feat(pitch): clickable live link on the title slide and every footer
Co-Authored-By: Claude Opus 5.5 <noreply@anthropic.com>
</commit_message>
<xml_diff>
--- a/pitch/Sehat-GRAVITON-2026.pptx
+++ b/pitch/Sehat-GRAVITON-2026.pptx
@@ -3322,7 +3322,7 @@
         </p:nvSpPr>
         <p:spPr>
           <a:xfrm>
-            <a:off x="640080" y="5303520"/>
+            <a:off x="640080" y="5074920"/>
             <a:ext cx="5486400" cy="365760"/>
           </a:xfrm>
           <a:prstGeom prst="rect">
@@ -3355,39 +3355,57 @@
       </p:sp>
       <p:sp>
         <p:nvSpPr>
-          <p:cNvPr id="8" name="TextBox 7"/>
-          <p:cNvSpPr txBox="1"/>
-          <p:nvPr/>
-        </p:nvSpPr>
-        <p:spPr>
-          <a:xfrm>
-            <a:off x="640080" y="5669280"/>
-            <a:ext cx="5486400" cy="365760"/>
-          </a:xfrm>
-          <a:prstGeom prst="rect">
-            <a:avLst/>
-          </a:prstGeom>
-          <a:noFill/>
-        </p:spPr>
-        <p:txBody>
-          <a:bodyPr wrap="square" anchor="t" lIns="45720" rIns="45720">
-            <a:spAutoFit/>
-          </a:bodyPr>
-          <a:lstStyle/>
-          <a:p>
-            <a:pPr algn="l">
-              <a:spcAft>
-                <a:spcPts val="800"/>
-              </a:spcAft>
-            </a:pPr>
-            <a:r>
-              <a:rPr sz="1400" b="0">
-                <a:solidFill>
-                  <a:srgbClr val="5B6B80"/>
-                </a:solidFill>
-                <a:latin typeface="Plus Jakarta Sans"/>
-              </a:rPr>
-              <a:t>Live: sehat-ashen.vercel.app</a:t>
+          <p:cNvPr id="8" name="Rounded Rectangle 7">
+            <a:hlinkClick r:id="rId2"/>
+          </p:cNvPr>
+          <p:cNvSpPr/>
+          <p:nvPr/>
+        </p:nvSpPr>
+        <p:spPr>
+          <a:xfrm>
+            <a:off x="640080" y="5623560"/>
+            <a:ext cx="4206240" cy="640080"/>
+          </a:xfrm>
+          <a:prstGeom prst="roundRect">
+            <a:avLst>
+              <a:gd name="adj" fmla="val 50000"/>
+            </a:avLst>
+          </a:prstGeom>
+          <a:solidFill>
+            <a:srgbClr val="0774C4"/>
+          </a:solidFill>
+          <a:ln>
+            <a:noFill/>
+          </a:ln>
+          <a:effectLst/>
+        </p:spPr>
+        <p:style>
+          <a:lnRef idx="1">
+            <a:schemeClr val="accent1"/>
+          </a:lnRef>
+          <a:fillRef idx="3">
+            <a:schemeClr val="accent1"/>
+          </a:fillRef>
+          <a:effectRef idx="2">
+            <a:schemeClr val="accent1"/>
+          </a:effectRef>
+          <a:fontRef idx="minor">
+            <a:schemeClr val="lt1"/>
+          </a:fontRef>
+        </p:style>
+        <p:txBody>
+          <a:bodyPr rtlCol="0" anchor="ctr"/>
+          <a:lstStyle/>
+          <a:p>
+            <a:pPr algn="ctr"/>
+            <a:r>
+              <a:rPr sz="1600" b="1">
+                <a:solidFill>
+                  <a:srgbClr val="FFFFFF"/>
+                </a:solidFill>
+                <a:latin typeface="Plus Jakarta Sans"/>
+              </a:rPr>
+              <a:t>🔗  Try it live: sehat-ashen.vercel.app</a:t>
             </a:r>
           </a:p>
         </p:txBody>
@@ -3449,7 +3467,7 @@
           <p:nvPr/>
         </p:nvPicPr>
         <p:blipFill>
-          <a:blip r:embed="rId2"/>
+          <a:blip r:embed="rId3"/>
           <a:stretch>
             <a:fillRect/>
           </a:stretch>
@@ -3638,7 +3656,17 @@
                 </a:solidFill>
                 <a:latin typeface="Plus Jakarta Sans"/>
               </a:rPr>
-              <a:t>Sehat  ·  Team ANTIJAREX  ·  GRAVITON 2026</a:t>
+              <a:t>Sehat  ·  Team ANTIJAREX  ·  GRAVITON 2026  ·  </a:t>
+            </a:r>
+            <a:r>
+              <a:rPr sz="1100" b="1">
+                <a:solidFill>
+                  <a:srgbClr val="0774C4"/>
+                </a:solidFill>
+                <a:latin typeface="Plus Jakarta Sans"/>
+                <a:hlinkClick r:id="rId2"/>
+              </a:rPr>
+              <a:t>sehat-ashen.vercel.app</a:t>
             </a:r>
           </a:p>
         </p:txBody>
@@ -4407,7 +4435,17 @@
                 </a:solidFill>
                 <a:latin typeface="Plus Jakarta Sans"/>
               </a:rPr>
-              <a:t>Sehat  ·  Team ANTIJAREX  ·  GRAVITON 2026</a:t>
+              <a:t>Sehat  ·  Team ANTIJAREX  ·  GRAVITON 2026  ·  </a:t>
+            </a:r>
+            <a:r>
+              <a:rPr sz="1100" b="1">
+                <a:solidFill>
+                  <a:srgbClr val="0774C4"/>
+                </a:solidFill>
+                <a:latin typeface="Plus Jakarta Sans"/>
+                <a:hlinkClick r:id="rId2"/>
+              </a:rPr>
+              <a:t>sehat-ashen.vercel.app</a:t>
             </a:r>
           </a:p>
         </p:txBody>
@@ -5255,7 +5293,17 @@
                 </a:solidFill>
                 <a:latin typeface="Plus Jakarta Sans"/>
               </a:rPr>
-              <a:t>Sehat  ·  Team ANTIJAREX  ·  GRAVITON 2026</a:t>
+              <a:t>Sehat  ·  Team ANTIJAREX  ·  GRAVITON 2026  ·  </a:t>
+            </a:r>
+            <a:r>
+              <a:rPr sz="1100" b="1">
+                <a:solidFill>
+                  <a:srgbClr val="0774C4"/>
+                </a:solidFill>
+                <a:latin typeface="Plus Jakarta Sans"/>
+                <a:hlinkClick r:id="rId2"/>
+              </a:rPr>
+              <a:t>sehat-ashen.vercel.app</a:t>
             </a:r>
           </a:p>
         </p:txBody>
@@ -6017,7 +6065,17 @@
                 </a:solidFill>
                 <a:latin typeface="Plus Jakarta Sans"/>
               </a:rPr>
-              <a:t>Sehat  ·  Team ANTIJAREX  ·  GRAVITON 2026</a:t>
+              <a:t>Sehat  ·  Team ANTIJAREX  ·  GRAVITON 2026  ·  </a:t>
+            </a:r>
+            <a:r>
+              <a:rPr sz="1100" b="1">
+                <a:solidFill>
+                  <a:srgbClr val="0774C4"/>
+                </a:solidFill>
+                <a:latin typeface="Plus Jakarta Sans"/>
+                <a:hlinkClick r:id="rId2"/>
+              </a:rPr>
+              <a:t>sehat-ashen.vercel.app</a:t>
             </a:r>
           </a:p>
         </p:txBody>
@@ -6611,7 +6669,17 @@
                 </a:solidFill>
                 <a:latin typeface="Plus Jakarta Sans"/>
               </a:rPr>
-              <a:t>Sehat  ·  Team ANTIJAREX  ·  GRAVITON 2026</a:t>
+              <a:t>Sehat  ·  Team ANTIJAREX  ·  GRAVITON 2026  ·  </a:t>
+            </a:r>
+            <a:r>
+              <a:rPr sz="1100" b="1">
+                <a:solidFill>
+                  <a:srgbClr val="0774C4"/>
+                </a:solidFill>
+                <a:latin typeface="Plus Jakarta Sans"/>
+                <a:hlinkClick r:id="rId2"/>
+              </a:rPr>
+              <a:t>sehat-ashen.vercel.app</a:t>
             </a:r>
           </a:p>
         </p:txBody>
@@ -7342,7 +7410,7 @@
           <p:nvPr/>
         </p:nvPicPr>
         <p:blipFill>
-          <a:blip r:embed="rId2"/>
+          <a:blip r:embed="rId3"/>
           <a:stretch>
             <a:fillRect/>
           </a:stretch>
@@ -7531,7 +7599,17 @@
                 </a:solidFill>
                 <a:latin typeface="Plus Jakarta Sans"/>
               </a:rPr>
-              <a:t>Sehat  ·  Team ANTIJAREX  ·  GRAVITON 2026</a:t>
+              <a:t>Sehat  ·  Team ANTIJAREX  ·  GRAVITON 2026  ·  </a:t>
+            </a:r>
+            <a:r>
+              <a:rPr sz="1100" b="1">
+                <a:solidFill>
+                  <a:srgbClr val="0774C4"/>
+                </a:solidFill>
+                <a:latin typeface="Plus Jakarta Sans"/>
+                <a:hlinkClick r:id="rId2"/>
+              </a:rPr>
+              <a:t>sehat-ashen.vercel.app</a:t>
             </a:r>
           </a:p>
         </p:txBody>
@@ -8336,7 +8414,7 @@
           <p:nvPr/>
         </p:nvPicPr>
         <p:blipFill>
-          <a:blip r:embed="rId2"/>
+          <a:blip r:embed="rId3"/>
           <a:stretch>
             <a:fillRect/>
           </a:stretch>
@@ -8408,7 +8486,7 @@
           <p:nvPr/>
         </p:nvPicPr>
         <p:blipFill>
-          <a:blip r:embed="rId3"/>
+          <a:blip r:embed="rId4"/>
           <a:stretch>
             <a:fillRect/>
           </a:stretch>
@@ -8597,7 +8675,17 @@
                 </a:solidFill>
                 <a:latin typeface="Plus Jakarta Sans"/>
               </a:rPr>
-              <a:t>Sehat  ·  Team ANTIJAREX  ·  GRAVITON 2026</a:t>
+              <a:t>Sehat  ·  Team ANTIJAREX  ·  GRAVITON 2026  ·  </a:t>
+            </a:r>
+            <a:r>
+              <a:rPr sz="1100" b="1">
+                <a:solidFill>
+                  <a:srgbClr val="0774C4"/>
+                </a:solidFill>
+                <a:latin typeface="Plus Jakarta Sans"/>
+                <a:hlinkClick r:id="rId2"/>
+              </a:rPr>
+              <a:t>sehat-ashen.vercel.app</a:t>
             </a:r>
           </a:p>
         </p:txBody>
@@ -9202,7 +9290,7 @@
           <p:nvPr/>
         </p:nvPicPr>
         <p:blipFill>
-          <a:blip r:embed="rId2"/>
+          <a:blip r:embed="rId3"/>
           <a:stretch>
             <a:fillRect/>
           </a:stretch>
@@ -9391,7 +9479,17 @@
                 </a:solidFill>
                 <a:latin typeface="Plus Jakarta Sans"/>
               </a:rPr>
-              <a:t>Sehat  ·  Team ANTIJAREX  ·  GRAVITON 2026</a:t>
+              <a:t>Sehat  ·  Team ANTIJAREX  ·  GRAVITON 2026  ·  </a:t>
+            </a:r>
+            <a:r>
+              <a:rPr sz="1100" b="1">
+                <a:solidFill>
+                  <a:srgbClr val="0774C4"/>
+                </a:solidFill>
+                <a:latin typeface="Plus Jakarta Sans"/>
+                <a:hlinkClick r:id="rId2"/>
+              </a:rPr>
+              <a:t>sehat-ashen.vercel.app</a:t>
             </a:r>
           </a:p>
         </p:txBody>
@@ -9996,7 +10094,7 @@
           <p:nvPr/>
         </p:nvPicPr>
         <p:blipFill>
-          <a:blip r:embed="rId2"/>
+          <a:blip r:embed="rId3"/>
           <a:stretch>
             <a:fillRect/>
           </a:stretch>
@@ -10185,7 +10283,17 @@
                 </a:solidFill>
                 <a:latin typeface="Plus Jakarta Sans"/>
               </a:rPr>
-              <a:t>Sehat  ·  Team ANTIJAREX  ·  GRAVITON 2026</a:t>
+              <a:t>Sehat  ·  Team ANTIJAREX  ·  GRAVITON 2026  ·  </a:t>
+            </a:r>
+            <a:r>
+              <a:rPr sz="1100" b="1">
+                <a:solidFill>
+                  <a:srgbClr val="0774C4"/>
+                </a:solidFill>
+                <a:latin typeface="Plus Jakarta Sans"/>
+                <a:hlinkClick r:id="rId2"/>
+              </a:rPr>
+              <a:t>sehat-ashen.vercel.app</a:t>
             </a:r>
           </a:p>
         </p:txBody>
@@ -10790,7 +10898,7 @@
           <p:nvPr/>
         </p:nvPicPr>
         <p:blipFill>
-          <a:blip r:embed="rId2"/>
+          <a:blip r:embed="rId3"/>
           <a:stretch>
             <a:fillRect/>
           </a:stretch>
@@ -10979,7 +11087,17 @@
                 </a:solidFill>
                 <a:latin typeface="Plus Jakarta Sans"/>
               </a:rPr>
-              <a:t>Sehat  ·  Team ANTIJAREX  ·  GRAVITON 2026</a:t>
+              <a:t>Sehat  ·  Team ANTIJAREX  ·  GRAVITON 2026  ·  </a:t>
+            </a:r>
+            <a:r>
+              <a:rPr sz="1100" b="1">
+                <a:solidFill>
+                  <a:srgbClr val="0774C4"/>
+                </a:solidFill>
+                <a:latin typeface="Plus Jakarta Sans"/>
+                <a:hlinkClick r:id="rId2"/>
+              </a:rPr>
+              <a:t>sehat-ashen.vercel.app</a:t>
             </a:r>
           </a:p>
         </p:txBody>

</xml_diff>

<commit_message>
feat(pitch): keep the live link only on the title slide
Co-Authored-By: Claude Opus 5.5 <noreply@anthropic.com>
</commit_message>
<xml_diff>
--- a/pitch/Sehat-GRAVITON-2026.pptx
+++ b/pitch/Sehat-GRAVITON-2026.pptx
@@ -3656,17 +3656,7 @@
                 </a:solidFill>
                 <a:latin typeface="Plus Jakarta Sans"/>
               </a:rPr>
-              <a:t>Sehat  ·  Team ANTIJAREX  ·  GRAVITON 2026  ·  </a:t>
-            </a:r>
-            <a:r>
-              <a:rPr sz="1100" b="1">
-                <a:solidFill>
-                  <a:srgbClr val="0774C4"/>
-                </a:solidFill>
-                <a:latin typeface="Plus Jakarta Sans"/>
-                <a:hlinkClick r:id="rId2"/>
-              </a:rPr>
-              <a:t>sehat-ashen.vercel.app</a:t>
+              <a:t>Sehat  ·  Team ANTIJAREX  ·  GRAVITON 2026</a:t>
             </a:r>
           </a:p>
         </p:txBody>
@@ -4435,17 +4425,7 @@
                 </a:solidFill>
                 <a:latin typeface="Plus Jakarta Sans"/>
               </a:rPr>
-              <a:t>Sehat  ·  Team ANTIJAREX  ·  GRAVITON 2026  ·  </a:t>
-            </a:r>
-            <a:r>
-              <a:rPr sz="1100" b="1">
-                <a:solidFill>
-                  <a:srgbClr val="0774C4"/>
-                </a:solidFill>
-                <a:latin typeface="Plus Jakarta Sans"/>
-                <a:hlinkClick r:id="rId2"/>
-              </a:rPr>
-              <a:t>sehat-ashen.vercel.app</a:t>
+              <a:t>Sehat  ·  Team ANTIJAREX  ·  GRAVITON 2026</a:t>
             </a:r>
           </a:p>
         </p:txBody>
@@ -5293,17 +5273,7 @@
                 </a:solidFill>
                 <a:latin typeface="Plus Jakarta Sans"/>
               </a:rPr>
-              <a:t>Sehat  ·  Team ANTIJAREX  ·  GRAVITON 2026  ·  </a:t>
-            </a:r>
-            <a:r>
-              <a:rPr sz="1100" b="1">
-                <a:solidFill>
-                  <a:srgbClr val="0774C4"/>
-                </a:solidFill>
-                <a:latin typeface="Plus Jakarta Sans"/>
-                <a:hlinkClick r:id="rId2"/>
-              </a:rPr>
-              <a:t>sehat-ashen.vercel.app</a:t>
+              <a:t>Sehat  ·  Team ANTIJAREX  ·  GRAVITON 2026</a:t>
             </a:r>
           </a:p>
         </p:txBody>
@@ -6065,17 +6035,7 @@
                 </a:solidFill>
                 <a:latin typeface="Plus Jakarta Sans"/>
               </a:rPr>
-              <a:t>Sehat  ·  Team ANTIJAREX  ·  GRAVITON 2026  ·  </a:t>
-            </a:r>
-            <a:r>
-              <a:rPr sz="1100" b="1">
-                <a:solidFill>
-                  <a:srgbClr val="0774C4"/>
-                </a:solidFill>
-                <a:latin typeface="Plus Jakarta Sans"/>
-                <a:hlinkClick r:id="rId2"/>
-              </a:rPr>
-              <a:t>sehat-ashen.vercel.app</a:t>
+              <a:t>Sehat  ·  Team ANTIJAREX  ·  GRAVITON 2026</a:t>
             </a:r>
           </a:p>
         </p:txBody>
@@ -6669,17 +6629,7 @@
                 </a:solidFill>
                 <a:latin typeface="Plus Jakarta Sans"/>
               </a:rPr>
-              <a:t>Sehat  ·  Team ANTIJAREX  ·  GRAVITON 2026  ·  </a:t>
-            </a:r>
-            <a:r>
-              <a:rPr sz="1100" b="1">
-                <a:solidFill>
-                  <a:srgbClr val="0774C4"/>
-                </a:solidFill>
-                <a:latin typeface="Plus Jakarta Sans"/>
-                <a:hlinkClick r:id="rId2"/>
-              </a:rPr>
-              <a:t>sehat-ashen.vercel.app</a:t>
+              <a:t>Sehat  ·  Team ANTIJAREX  ·  GRAVITON 2026</a:t>
             </a:r>
           </a:p>
         </p:txBody>
@@ -7410,7 +7360,7 @@
           <p:nvPr/>
         </p:nvPicPr>
         <p:blipFill>
-          <a:blip r:embed="rId3"/>
+          <a:blip r:embed="rId2"/>
           <a:stretch>
             <a:fillRect/>
           </a:stretch>
@@ -7599,17 +7549,7 @@
                 </a:solidFill>
                 <a:latin typeface="Plus Jakarta Sans"/>
               </a:rPr>
-              <a:t>Sehat  ·  Team ANTIJAREX  ·  GRAVITON 2026  ·  </a:t>
-            </a:r>
-            <a:r>
-              <a:rPr sz="1100" b="1">
-                <a:solidFill>
-                  <a:srgbClr val="0774C4"/>
-                </a:solidFill>
-                <a:latin typeface="Plus Jakarta Sans"/>
-                <a:hlinkClick r:id="rId2"/>
-              </a:rPr>
-              <a:t>sehat-ashen.vercel.app</a:t>
+              <a:t>Sehat  ·  Team ANTIJAREX  ·  GRAVITON 2026</a:t>
             </a:r>
           </a:p>
         </p:txBody>
@@ -8414,7 +8354,7 @@
           <p:nvPr/>
         </p:nvPicPr>
         <p:blipFill>
-          <a:blip r:embed="rId3"/>
+          <a:blip r:embed="rId2"/>
           <a:stretch>
             <a:fillRect/>
           </a:stretch>
@@ -8486,7 +8426,7 @@
           <p:nvPr/>
         </p:nvPicPr>
         <p:blipFill>
-          <a:blip r:embed="rId4"/>
+          <a:blip r:embed="rId3"/>
           <a:stretch>
             <a:fillRect/>
           </a:stretch>
@@ -8675,17 +8615,7 @@
                 </a:solidFill>
                 <a:latin typeface="Plus Jakarta Sans"/>
               </a:rPr>
-              <a:t>Sehat  ·  Team ANTIJAREX  ·  GRAVITON 2026  ·  </a:t>
-            </a:r>
-            <a:r>
-              <a:rPr sz="1100" b="1">
-                <a:solidFill>
-                  <a:srgbClr val="0774C4"/>
-                </a:solidFill>
-                <a:latin typeface="Plus Jakarta Sans"/>
-                <a:hlinkClick r:id="rId2"/>
-              </a:rPr>
-              <a:t>sehat-ashen.vercel.app</a:t>
+              <a:t>Sehat  ·  Team ANTIJAREX  ·  GRAVITON 2026</a:t>
             </a:r>
           </a:p>
         </p:txBody>
@@ -9290,7 +9220,7 @@
           <p:nvPr/>
         </p:nvPicPr>
         <p:blipFill>
-          <a:blip r:embed="rId3"/>
+          <a:blip r:embed="rId2"/>
           <a:stretch>
             <a:fillRect/>
           </a:stretch>
@@ -9479,17 +9409,7 @@
                 </a:solidFill>
                 <a:latin typeface="Plus Jakarta Sans"/>
               </a:rPr>
-              <a:t>Sehat  ·  Team ANTIJAREX  ·  GRAVITON 2026  ·  </a:t>
-            </a:r>
-            <a:r>
-              <a:rPr sz="1100" b="1">
-                <a:solidFill>
-                  <a:srgbClr val="0774C4"/>
-                </a:solidFill>
-                <a:latin typeface="Plus Jakarta Sans"/>
-                <a:hlinkClick r:id="rId2"/>
-              </a:rPr>
-              <a:t>sehat-ashen.vercel.app</a:t>
+              <a:t>Sehat  ·  Team ANTIJAREX  ·  GRAVITON 2026</a:t>
             </a:r>
           </a:p>
         </p:txBody>
@@ -10094,7 +10014,7 @@
           <p:nvPr/>
         </p:nvPicPr>
         <p:blipFill>
-          <a:blip r:embed="rId3"/>
+          <a:blip r:embed="rId2"/>
           <a:stretch>
             <a:fillRect/>
           </a:stretch>
@@ -10283,17 +10203,7 @@
                 </a:solidFill>
                 <a:latin typeface="Plus Jakarta Sans"/>
               </a:rPr>
-              <a:t>Sehat  ·  Team ANTIJAREX  ·  GRAVITON 2026  ·  </a:t>
-            </a:r>
-            <a:r>
-              <a:rPr sz="1100" b="1">
-                <a:solidFill>
-                  <a:srgbClr val="0774C4"/>
-                </a:solidFill>
-                <a:latin typeface="Plus Jakarta Sans"/>
-                <a:hlinkClick r:id="rId2"/>
-              </a:rPr>
-              <a:t>sehat-ashen.vercel.app</a:t>
+              <a:t>Sehat  ·  Team ANTIJAREX  ·  GRAVITON 2026</a:t>
             </a:r>
           </a:p>
         </p:txBody>
@@ -10898,7 +10808,7 @@
           <p:nvPr/>
         </p:nvPicPr>
         <p:blipFill>
-          <a:blip r:embed="rId3"/>
+          <a:blip r:embed="rId2"/>
           <a:stretch>
             <a:fillRect/>
           </a:stretch>
@@ -11087,17 +10997,7 @@
                 </a:solidFill>
                 <a:latin typeface="Plus Jakarta Sans"/>
               </a:rPr>
-              <a:t>Sehat  ·  Team ANTIJAREX  ·  GRAVITON 2026  ·  </a:t>
-            </a:r>
-            <a:r>
-              <a:rPr sz="1100" b="1">
-                <a:solidFill>
-                  <a:srgbClr val="0774C4"/>
-                </a:solidFill>
-                <a:latin typeface="Plus Jakarta Sans"/>
-                <a:hlinkClick r:id="rId2"/>
-              </a:rPr>
-              <a:t>sehat-ashen.vercel.app</a:t>
+              <a:t>Sehat  ·  Team ANTIJAREX  ·  GRAVITON 2026</a:t>
             </a:r>
           </a:p>
         </p:txBody>

</xml_diff>